<commit_message>
Abb. 2.2: Auslassungspunkte entfernt (Revision MD 06.10.2026)
Co-Authored-By: Claude Opus 5.5 <noreply@anthropic.com>
Claude-Session: https://claude.ai/code/session_015a49Vr6vK6JHdw6trSezHk
</commit_message>
<xml_diff>
--- a/abbildungen/kap2/Zeitdimensionen_der_Unternehmensfuehrung.pptx
+++ b/abbildungen/kap2/Zeitdimensionen_der_Unternehmensfuehrung.pptx
@@ -7,7 +7,7 @@
   <p:sldIdLst>
     <p:sldId id="256" r:id="rId7"/>
   </p:sldIdLst>
-  <p:sldSz cx="3960000" cy="3153600" type="screen4x3"/>
+  <p:sldSz cx="3960000" cy="2836800" type="screen4x3"/>
   <p:notesSz cx="6858000" cy="9144000"/>
   <p:defaultTextStyle>
     <a:defPPr>
@@ -3097,11 +3097,11 @@
         <p:spPr>
           <a:xfrm>
             <a:off x="10800" y="10800"/>
-            <a:ext cx="3938400" cy="3132000"/>
+            <a:ext cx="3938400" cy="2815200"/>
           </a:xfrm>
           <a:prstGeom prst="roundRect">
             <a:avLst>
-              <a:gd name="adj" fmla="val 1379"/>
+              <a:gd name="adj" fmla="val 1535"/>
             </a:avLst>
           </a:prstGeom>
           <a:noFill/>
@@ -3258,11 +3258,11 @@
         <p:spPr>
           <a:xfrm>
             <a:off x="504000" y="662400"/>
-            <a:ext cx="2232000" cy="462808"/>
+            <a:ext cx="2232000" cy="357906"/>
           </a:xfrm>
           <a:prstGeom prst="roundRect">
             <a:avLst>
-              <a:gd name="adj" fmla="val 6223"/>
+              <a:gd name="adj" fmla="val 8047"/>
             </a:avLst>
           </a:prstGeom>
           <a:solidFill>
@@ -3333,24 +3333,6 @@
               <a:t>Regionen</a:t>
             </a:r>
           </a:p>
-          <a:p>
-            <a:pPr algn="l" marL="79200" indent="-79200">
-              <a:lnSpc>
-                <a:spcPts val="826"/>
-              </a:lnSpc>
-              <a:buFont typeface="Arial"/>
-              <a:buChar char="•"/>
-            </a:pPr>
-            <a:r>
-              <a:rPr lang="de-DE" sz="700" b="0" i="0">
-                <a:solidFill>
-                  <a:srgbClr val="1A1A1A"/>
-                </a:solidFill>
-                <a:latin typeface="Arial"/>
-              </a:rPr>
-              <a:t>…</a:t>
-            </a:r>
-          </a:p>
         </p:txBody>
       </p:sp>
       <p:sp>
@@ -3361,7 +3343,7 @@
         </p:nvSpPr>
         <p:spPr>
           <a:xfrm>
-            <a:off x="2880000" y="814604"/>
+            <a:off x="2880000" y="762153"/>
             <a:ext cx="972000" cy="158400"/>
           </a:xfrm>
           <a:prstGeom prst="rect">
@@ -3401,12 +3383,12 @@
         </p:nvSpPr>
         <p:spPr>
           <a:xfrm>
-            <a:off x="504000" y="1276408"/>
-            <a:ext cx="2232000" cy="462808"/>
+            <a:off x="504000" y="1171506"/>
+            <a:ext cx="2232000" cy="357906"/>
           </a:xfrm>
           <a:prstGeom prst="roundRect">
             <a:avLst>
-              <a:gd name="adj" fmla="val 6223"/>
+              <a:gd name="adj" fmla="val 8047"/>
             </a:avLst>
           </a:prstGeom>
           <a:solidFill>
@@ -3477,24 +3459,6 @@
               <a:t>Projekte</a:t>
             </a:r>
           </a:p>
-          <a:p>
-            <a:pPr algn="l" marL="79200" indent="-79200">
-              <a:lnSpc>
-                <a:spcPts val="826"/>
-              </a:lnSpc>
-              <a:buFont typeface="Arial"/>
-              <a:buChar char="•"/>
-            </a:pPr>
-            <a:r>
-              <a:rPr lang="de-DE" sz="700" b="0" i="0">
-                <a:solidFill>
-                  <a:srgbClr val="1A1A1A"/>
-                </a:solidFill>
-                <a:latin typeface="Arial"/>
-              </a:rPr>
-              <a:t>…</a:t>
-            </a:r>
-          </a:p>
         </p:txBody>
       </p:sp>
       <p:sp>
@@ -3505,7 +3469,7 @@
         </p:nvSpPr>
         <p:spPr>
           <a:xfrm>
-            <a:off x="2880000" y="1428612"/>
+            <a:off x="2880000" y="1271259"/>
             <a:ext cx="972000" cy="158400"/>
           </a:xfrm>
           <a:prstGeom prst="rect">
@@ -3545,12 +3509,12 @@
         </p:nvSpPr>
         <p:spPr>
           <a:xfrm>
-            <a:off x="504000" y="1890416"/>
-            <a:ext cx="2232000" cy="462808"/>
+            <a:off x="504000" y="1680612"/>
+            <a:ext cx="2232000" cy="357906"/>
           </a:xfrm>
           <a:prstGeom prst="roundRect">
             <a:avLst>
-              <a:gd name="adj" fmla="val 6223"/>
+              <a:gd name="adj" fmla="val 8047"/>
             </a:avLst>
           </a:prstGeom>
           <a:solidFill>
@@ -3621,24 +3585,6 @@
               <a:t>Ressourcen</a:t>
             </a:r>
           </a:p>
-          <a:p>
-            <a:pPr algn="l" marL="79200" indent="-79200">
-              <a:lnSpc>
-                <a:spcPts val="826"/>
-              </a:lnSpc>
-              <a:buFont typeface="Arial"/>
-              <a:buChar char="•"/>
-            </a:pPr>
-            <a:r>
-              <a:rPr lang="de-DE" sz="700" b="0" i="0">
-                <a:solidFill>
-                  <a:srgbClr val="1A1A1A"/>
-                </a:solidFill>
-                <a:latin typeface="Arial"/>
-              </a:rPr>
-              <a:t>…</a:t>
-            </a:r>
-          </a:p>
         </p:txBody>
       </p:sp>
       <p:sp>
@@ -3649,7 +3595,7 @@
         </p:nvSpPr>
         <p:spPr>
           <a:xfrm>
-            <a:off x="2880000" y="2042620"/>
+            <a:off x="2880000" y="1780365"/>
             <a:ext cx="972000" cy="158400"/>
           </a:xfrm>
           <a:prstGeom prst="rect">
@@ -3689,7 +3635,7 @@
         </p:nvSpPr>
         <p:spPr>
           <a:xfrm>
-            <a:off x="504000" y="2504424"/>
+            <a:off x="504000" y="2189718"/>
             <a:ext cx="2232000" cy="201600"/>
           </a:xfrm>
           <a:prstGeom prst="roundRect">
@@ -3739,7 +3685,7 @@
         </p:nvSpPr>
         <p:spPr>
           <a:xfrm>
-            <a:off x="504000" y="2857224"/>
+            <a:off x="504000" y="2542518"/>
             <a:ext cx="2232000" cy="201600"/>
           </a:xfrm>
           <a:prstGeom prst="roundRect">
@@ -3834,7 +3780,7 @@
         </p:nvSpPr>
         <p:spPr>
           <a:xfrm>
-            <a:off x="2412000" y="1125208"/>
+            <a:off x="2412000" y="1020306"/>
             <a:ext cx="0" cy="151200"/>
           </a:xfrm>
           <a:custGeom>
@@ -3879,7 +3825,7 @@
         </p:nvSpPr>
         <p:spPr>
           <a:xfrm>
-            <a:off x="2412000" y="1739216"/>
+            <a:off x="2412000" y="1529412"/>
             <a:ext cx="0" cy="151200"/>
           </a:xfrm>
           <a:custGeom>
@@ -3924,7 +3870,7 @@
         </p:nvSpPr>
         <p:spPr>
           <a:xfrm>
-            <a:off x="2412000" y="2353224"/>
+            <a:off x="2412000" y="2038518"/>
             <a:ext cx="0" cy="151200"/>
           </a:xfrm>
           <a:custGeom>
@@ -3969,7 +3915,7 @@
         </p:nvSpPr>
         <p:spPr>
           <a:xfrm>
-            <a:off x="2412000" y="2706024"/>
+            <a:off x="2412000" y="2391318"/>
             <a:ext cx="0" cy="151200"/>
           </a:xfrm>
           <a:custGeom>
@@ -4014,7 +3960,7 @@
         </p:nvSpPr>
         <p:spPr>
           <a:xfrm>
-            <a:off x="936000" y="2706024"/>
+            <a:off x="936000" y="2391318"/>
             <a:ext cx="0" cy="151200"/>
           </a:xfrm>
           <a:custGeom>
@@ -4060,7 +4006,7 @@
         <p:spPr>
           <a:xfrm>
             <a:off x="216000" y="410400"/>
-            <a:ext cx="288000" cy="2194824"/>
+            <a:ext cx="288000" cy="1880118"/>
           </a:xfrm>
           <a:custGeom>
             <a:avLst/>
@@ -4069,7 +4015,7 @@
             <a:cxnLst/>
             <a:rect l="l" t="t" r="r" b="b"/>
             <a:pathLst>
-              <a:path w="288000" h="2194824">
+              <a:path w="288000" h="1880118">
                 <a:moveTo>
                   <a:pt x="288000" y="0"/>
                 </a:moveTo>
@@ -4077,7 +4023,7 @@
                   <a:pt x="0" y="0"/>
                 </a:lnTo>
                 <a:lnTo>
-                  <a:pt x="0" y="2194824"/>
+                  <a:pt x="0" y="1880118"/>
                 </a:lnTo>
               </a:path>
             </a:pathLst>
@@ -4106,7 +4052,7 @@
         </p:nvSpPr>
         <p:spPr>
           <a:xfrm>
-            <a:off x="216000" y="893804"/>
+            <a:off x="216000" y="841353"/>
             <a:ext cx="288000" cy="0"/>
           </a:xfrm>
           <a:custGeom>
@@ -4151,7 +4097,7 @@
         </p:nvSpPr>
         <p:spPr>
           <a:xfrm>
-            <a:off x="199800" y="877604"/>
+            <a:off x="199800" y="825153"/>
             <a:ext cx="32400" cy="32400"/>
           </a:xfrm>
           <a:prstGeom prst="ellipse">
@@ -4180,7 +4126,7 @@
         </p:nvSpPr>
         <p:spPr>
           <a:xfrm>
-            <a:off x="216000" y="1507812"/>
+            <a:off x="216000" y="1350459"/>
             <a:ext cx="288000" cy="0"/>
           </a:xfrm>
           <a:custGeom>
@@ -4225,7 +4171,7 @@
         </p:nvSpPr>
         <p:spPr>
           <a:xfrm>
-            <a:off x="199800" y="1491612"/>
+            <a:off x="199800" y="1334259"/>
             <a:ext cx="32400" cy="32400"/>
           </a:xfrm>
           <a:prstGeom prst="ellipse">
@@ -4254,7 +4200,7 @@
         </p:nvSpPr>
         <p:spPr>
           <a:xfrm>
-            <a:off x="216000" y="2121820"/>
+            <a:off x="216000" y="1859565"/>
             <a:ext cx="288000" cy="0"/>
           </a:xfrm>
           <a:custGeom>
@@ -4299,7 +4245,7 @@
         </p:nvSpPr>
         <p:spPr>
           <a:xfrm>
-            <a:off x="199800" y="2105620"/>
+            <a:off x="199800" y="1843365"/>
             <a:ext cx="32400" cy="32400"/>
           </a:xfrm>
           <a:prstGeom prst="ellipse">
@@ -4328,7 +4274,7 @@
         </p:nvSpPr>
         <p:spPr>
           <a:xfrm>
-            <a:off x="216000" y="2605224"/>
+            <a:off x="216000" y="2290518"/>
             <a:ext cx="288000" cy="0"/>
           </a:xfrm>
           <a:custGeom>

</xml_diff>

<commit_message>
Revision Abb. 2.2: Knotenpunkte an den Pfeilen links entfernt (DS)
- Rückmeldung „Nächste Version“ für die Tabelle; die noch nicht übernommene
  Rückmeldung vom 06.10. ist darin zusammengefasst
- Code.gs: mailJetztSenden schickt anstehende Meldungen ohne Ruhezeit

Co-Authored-By: Claude Opus 5.5 <noreply@anthropic.com>
Claude-Session: https://claude.ai/code/session_015a49Vr6vK6JHdw6trSezHk
</commit_message>
<xml_diff>
--- a/abbildungen/kap2/Zeitdimensionen_der_Unternehmensfuehrung.pptx
+++ b/abbildungen/kap2/Zeitdimensionen_der_Unternehmensfuehrung.pptx
@@ -4091,36 +4091,7 @@
       </p:sp>
       <p:sp>
         <p:nvSpPr>
-          <p:cNvPr id="22" name="Knoten"/>
-          <p:cNvSpPr/>
-          <p:nvPr/>
-        </p:nvSpPr>
-        <p:spPr>
-          <a:xfrm>
-            <a:off x="199800" y="825153"/>
-            <a:ext cx="32400" cy="32400"/>
-          </a:xfrm>
-          <a:prstGeom prst="ellipse">
-            <a:avLst/>
-          </a:prstGeom>
-          <a:solidFill>
-            <a:srgbClr val="3A3F44"/>
-          </a:solidFill>
-          <a:ln>
-            <a:noFill/>
-          </a:ln>
-        </p:spPr>
-        <p:txBody>
-          <a:bodyPr rtlCol="0" anchor="ctr"/>
-          <a:lstStyle/>
-          <a:p>
-            <a:pPr algn="ctr"/>
-          </a:p>
-        </p:txBody>
-      </p:sp>
-      <p:sp>
-        <p:nvSpPr>
-          <p:cNvPr id="23" name="Freeform 22"/>
+          <p:cNvPr id="22" name="Freeform 21"/>
           <p:cNvSpPr/>
           <p:nvPr/>
         </p:nvSpPr>
@@ -4165,36 +4136,7 @@
       </p:sp>
       <p:sp>
         <p:nvSpPr>
-          <p:cNvPr id="24" name="Knoten"/>
-          <p:cNvSpPr/>
-          <p:nvPr/>
-        </p:nvSpPr>
-        <p:spPr>
-          <a:xfrm>
-            <a:off x="199800" y="1334259"/>
-            <a:ext cx="32400" cy="32400"/>
-          </a:xfrm>
-          <a:prstGeom prst="ellipse">
-            <a:avLst/>
-          </a:prstGeom>
-          <a:solidFill>
-            <a:srgbClr val="3A3F44"/>
-          </a:solidFill>
-          <a:ln>
-            <a:noFill/>
-          </a:ln>
-        </p:spPr>
-        <p:txBody>
-          <a:bodyPr rtlCol="0" anchor="ctr"/>
-          <a:lstStyle/>
-          <a:p>
-            <a:pPr algn="ctr"/>
-          </a:p>
-        </p:txBody>
-      </p:sp>
-      <p:sp>
-        <p:nvSpPr>
-          <p:cNvPr id="25" name="Freeform 24"/>
+          <p:cNvPr id="23" name="Freeform 22"/>
           <p:cNvSpPr/>
           <p:nvPr/>
         </p:nvSpPr>
@@ -4239,36 +4181,7 @@
       </p:sp>
       <p:sp>
         <p:nvSpPr>
-          <p:cNvPr id="26" name="Knoten"/>
-          <p:cNvSpPr/>
-          <p:nvPr/>
-        </p:nvSpPr>
-        <p:spPr>
-          <a:xfrm>
-            <a:off x="199800" y="1843365"/>
-            <a:ext cx="32400" cy="32400"/>
-          </a:xfrm>
-          <a:prstGeom prst="ellipse">
-            <a:avLst/>
-          </a:prstGeom>
-          <a:solidFill>
-            <a:srgbClr val="3A3F44"/>
-          </a:solidFill>
-          <a:ln>
-            <a:noFill/>
-          </a:ln>
-        </p:spPr>
-        <p:txBody>
-          <a:bodyPr rtlCol="0" anchor="ctr"/>
-          <a:lstStyle/>
-          <a:p>
-            <a:pPr algn="ctr"/>
-          </a:p>
-        </p:txBody>
-      </p:sp>
-      <p:sp>
-        <p:nvSpPr>
-          <p:cNvPr id="27" name="Freeform 26"/>
+          <p:cNvPr id="24" name="Freeform 23"/>
           <p:cNvSpPr/>
           <p:nvPr/>
         </p:nvSpPr>

</xml_diff>